<commit_message>
fix(soutenance): refleter la confirmation DPO beta=0,3 a l'echelle reelle
Rebase sur main (commit local avance depuis le lancement de cette
branche) : le run complet a 5000 exemples avec beta=0,3 confirme
F1=0,110 (quasi identique au post-SFT, aucune regression par rapport
au checkpoint pas cher a 100). Met a jour les diapositives DPO
(run 5000, cause/correction, synthese, conclusions) pour retirer la
mention "a confirmer" devenue obsolete et citer les chiffres finaux.
</commit_message>
<xml_diff>
--- a/docs/00_cadrage/05_presentation_soutenance.pptx
+++ b/docs/00_cadrage/05_presentation_soutenance.pptx
@@ -731,7 +731,7 @@
           <a:lstStyle/>
           <a:p>
             <a:r>
-              <a:t>Jobs d'evaluation reels : 6ab393352... beta=0,1 sans repetition_penalty (F1=0,049) ; 6ab3adaa52d0dbd7f1d8445b beta=0,1 + repetition_penalty=1,2 (F1=0,063) ; 6ab3c38a52d0dbd7f1d84c5c beta=0,3 + repetition_penalty=1,2 (F1=0,112). Prochaine etape non encore realisee : rengager le run complet a 5000 avec beta=0,3 pour confirmer ce gain a l'echelle reelle, avant de considerer l'hyperparametre valide.</a:t>
+              <a:t>Jobs d'evaluation reels : 6ab3933152d0dbd7f1d83a16 beta=0,1 sans repetition_penalty (F1=0,049) ; 6ab3adaa52d0dbd7f1d8445b beta=0,1 + repetition_penalty=1,2 (F1=0,063) ; 6ab3c38a52d0dbd7f1d84c5c beta=0,3 (checkpoint 100) + repetition_penalty=1,2 (F1=0,112) ; 6ab40ee752d0dbd7f1d86485 beta=0,3 (checkpoint 5000, job d'entrainement 6ab3f52a51992417dfcd7fe5) + repetition_penalty=1,2 (F1=0,110). beta=0,3 est desormais l'hyperparametre retenu pour ce projet.</a:t>
             </a:r>
           </a:p>
         </p:txBody>
@@ -4115,7 +4115,7 @@
               </a:defRPr>
             </a:pPr>
             <a:r>
-              <a:t>Cahier des charges §7, Livrable 1</a:t>
+              <a:t>Cahier des charges §7, Livrable 1 - premier run a l'echelle reelle</a:t>
             </a:r>
           </a:p>
         </p:txBody>
@@ -4337,6 +4337,21 @@
             </a:pPr>
             <a:r>
               <a:t>• Confirme la lecture faite a 100 exemples : le verdict sous_apprentissage etait un faux negatif du seuil herite du SFT, pas un echec d'apprentissage. Poids publies : mombasstic/chsa-triage-dpo-lora.</a:t>
+            </a:r>
+          </a:p>
+          <a:p>
+            <a:pPr>
+              <a:spcAft>
+                <a:spcPts val="1200"/>
+              </a:spcAft>
+              <a:defRPr sz="1500">
+                <a:solidFill>
+                  <a:srgbClr val="333333"/>
+                </a:solidFill>
+              </a:defRPr>
+            </a:pPr>
+            <a:r>
+              <a:t>• Ce premier run a l'echelle reelle utilise encore beta=0,1 : l'evaluation qui suit (3.3) y decouvre un probleme reel, corrige puis reconfirme a cette meme echelle.</a:t>
             </a:r>
           </a:p>
         </p:txBody>
@@ -5026,7 +5041,7 @@
               </a:defRPr>
             </a:pPr>
             <a:r>
-              <a:t>3.3 Cause racine et correction</a:t>
+              <a:t>3.3 Cause racine, correction, confirmation a l'echelle</a:t>
             </a:r>
           </a:p>
           <a:p>
@@ -5091,7 +5106,7 @@
               </a:defRPr>
             </a:pPr>
             <a:r>
-              <a:t>• beta releve a 0,3 dans la recette pour tester cette hypothese, validee d'abord sur le checkpoint pas cher a 100 exemples avant de rengager un run a 5000.</a:t>
+              <a:t>• beta releve a 0,3 : gain confirme d'abord sur le checkpoint pas cher a 100 exemples, PUIS sur le run complet a 5000 (verdict saine, rewards/accuracies=0,75) - aucune regression en passant a l'echelle.</a:t>
             </a:r>
           </a:p>
         </p:txBody>
@@ -5106,7 +5121,7 @@
         </p:nvGraphicFramePr>
         <p:xfrm>
           <a:off x="822960" y="3749039"/>
-          <a:ext cx="10515600" cy="1828800"/>
+          <a:ext cx="10972800" cy="2286000"/>
         </p:xfrm>
         <a:graphic>
           <a:graphicData uri="http://schemas.openxmlformats.org/drawingml/2006/table">
@@ -5115,7 +5130,7 @@
                 <a:tableStyleId>{5C22544A-7EE6-4342-B048-85BDC9FD1C3A}</a:tableStyleId>
               </a:tblPr>
               <a:tblGrid>
-                <a:gridCol w="4572000"/>
+                <a:gridCol w="5029200"/>
                 <a:gridCol w="3200400"/>
                 <a:gridCol w="2743200"/>
               </a:tblGrid>
@@ -5133,7 +5148,7 @@
                         </a:defRPr>
                       </a:pPr>
                       <a:r>
-                        <a:t>Checkpoint (100 ex.)</a:t>
+                        <a:t>Checkpoint</a:t>
                       </a:r>
                     </a:p>
                   </a:txBody>
@@ -5204,7 +5219,7 @@
                         </a:defRPr>
                       </a:pPr>
                       <a:r>
-                        <a:t>beta=0,1</a:t>
+                        <a:t>beta=0,1 (5000)</a:t>
                       </a:r>
                     </a:p>
                   </a:txBody>
@@ -5263,7 +5278,7 @@
                         </a:defRPr>
                       </a:pPr>
                       <a:r>
-                        <a:t>beta=0,1</a:t>
+                        <a:t>beta=0,1 (5000)</a:t>
                       </a:r>
                     </a:p>
                   </a:txBody>
@@ -5322,7 +5337,66 @@
                         </a:defRPr>
                       </a:pPr>
                       <a:r>
-                        <a:t>beta=0,3</a:t>
+                        <a:t>beta=0,3 (100, verification)</a:t>
+                      </a:r>
+                    </a:p>
+                  </a:txBody>
+                  <a:tcPr/>
+                </a:tc>
+                <a:tc>
+                  <a:txBody>
+                    <a:bodyPr/>
+                    <a:lstStyle/>
+                    <a:p>
+                      <a:pPr>
+                        <a:defRPr sz="1500">
+                          <a:solidFill>
+                            <a:srgbClr val="333333"/>
+                          </a:solidFill>
+                        </a:defRPr>
+                      </a:pPr>
+                      <a:r>
+                        <a:t>1,2</a:t>
+                      </a:r>
+                    </a:p>
+                  </a:txBody>
+                  <a:tcPr/>
+                </a:tc>
+                <a:tc>
+                  <a:txBody>
+                    <a:bodyPr/>
+                    <a:lstStyle/>
+                    <a:p>
+                      <a:pPr>
+                        <a:defRPr sz="1500">
+                          <a:solidFill>
+                            <a:srgbClr val="333333"/>
+                          </a:solidFill>
+                        </a:defRPr>
+                      </a:pPr>
+                      <a:r>
+                        <a:t>0,112 (= post-SFT)</a:t>
+                      </a:r>
+                    </a:p>
+                  </a:txBody>
+                  <a:tcPr/>
+                </a:tc>
+              </a:tr>
+              <a:tr h="457200">
+                <a:tc>
+                  <a:txBody>
+                    <a:bodyPr/>
+                    <a:lstStyle/>
+                    <a:p>
+                      <a:pPr>
+                        <a:defRPr sz="1500">
+                          <a:solidFill>
+                            <a:srgbClr val="333333"/>
+                          </a:solidFill>
+                        </a:defRPr>
+                      </a:pPr>
+                      <a:r>
+                        <a:t>beta=0,3 (5000, echelle reelle)</a:t>
                       </a:r>
                     </a:p>
                   </a:txBody>
@@ -5360,7 +5434,7 @@
                         </a:defRPr>
                       </a:pPr>
                       <a:r>
-                        <a:t>0,112 (= post-SFT)</a:t>
+                        <a:t>0,110 (= post-SFT)</a:t>
                       </a:r>
                     </a:p>
                   </a:txBody>
@@ -5513,7 +5587,7 @@
               </a:defRPr>
             </a:pPr>
             <a:r>
-              <a:t>• Parametres DPO retenus : beta=0,3, taux_apprentissage=5e-5, taille_lot=4, per_device_eval_batch_size=4, repetition_penalty=1,2 a l'inference (beta=0,3 valide au run pas cher a 100 exemples ; confirmation a 5000 = prochaine etape).</a:t>
+              <a:t>• Parametres DPO retenus (finaux) : beta=0,3, taux_apprentissage=5e-5, taille_lot=4, per_device_eval_batch_size=4, repetition_penalty=1,2 a l'inference - confirmes a l'echelle reelle (5000 exemples), aucune regression par rapport au run pas cher a 100.</a:t>
             </a:r>
           </a:p>
           <a:p>
@@ -5926,7 +6000,7 @@
                         </a:defRPr>
                       </a:pPr>
                       <a:r>
-                        <a:t>Post-DPO (beta=0,1)</a:t>
+                        <a:t>Post-DPO (beta=0,3, retenu)</a:t>
                       </a:r>
                     </a:p>
                   </a:txBody>
@@ -5964,7 +6038,7 @@
                         </a:defRPr>
                       </a:pPr>
                       <a:r>
-                        <a:t>0,049</a:t>
+                        <a:t>0,110</a:t>
                       </a:r>
                     </a:p>
                   </a:txBody>
@@ -5983,7 +6057,7 @@
                         </a:defRPr>
                       </a:pPr>
                       <a:r>
-                        <a:t>~12,0 s</a:t>
+                        <a:t>~11,2 s</a:t>
                       </a:r>
                     </a:p>
                   </a:txBody>
@@ -6715,7 +6789,7 @@
               </a:defRPr>
             </a:pPr>
             <a:r>
-              <a:t>• Etape 3 (DPO) : entrainee avec succes a l'echelle reelle (verdict saine, rewards/accuracies=0,725) ; degenerescence a l'evaluation diagnostiquee et corrigee (beta=0,3 + repetition_penalty=1,2), validee pour l'instant seulement au run pas cher a 100 exemples.</a:t>
+              <a:t>• Etape 3 (DPO) : entrainee avec succes a l'echelle reelle ; degenerescence a l'evaluation diagnostiquee et corrigee (beta=0,3 + repetition_penalty=1,2), gain confirme a l'echelle reelle (F1=0,110, quasi identique au post-SFT, aucune regression en passant de 100 a 5000 exemples).</a:t>
             </a:r>
           </a:p>
           <a:p>
@@ -6865,22 +6939,7 @@
               </a:defRPr>
             </a:pPr>
             <a:r>
-              <a:t>• Confirmer beta=0,3 sur le run complet a 5000 exemples (prochaine etape immediate, pas encore lancee).</a:t>
-            </a:r>
-          </a:p>
-          <a:p>
-            <a:pPr>
-              <a:spcAft>
-                <a:spcPts val="1200"/>
-              </a:spcAft>
-              <a:defRPr sz="1700">
-                <a:solidFill>
-                  <a:srgbClr val="333333"/>
-                </a:solidFill>
-              </a:defRPr>
-            </a:pPr>
-            <a:r>
-              <a:t>• Garde-fou de securite clinique NF4 (juge LLM) : decision produit encore ouverte, non implemente.</a:t>
+              <a:t>• Garde-fou de securite clinique NF4 (juge LLM, safety &lt; 4/7) : decision produit encore ouverte, non implemente.</a:t>
             </a:r>
           </a:p>
           <a:p>
@@ -7365,7 +7424,7 @@
               </a:defRPr>
             </a:pPr>
             <a:r>
-              <a:t>72,5 %</a:t>
+              <a:t>75 %</a:t>
             </a:r>
           </a:p>
           <a:p>
@@ -7377,11 +7436,11 @@
               </a:defRPr>
             </a:pPr>
             <a:r>
-              <a:t>rewards/accuracies DPO</a:t>
+              <a:t>rewards/accuracies DPO retenu</a:t>
             </a:r>
             <a:br/>
             <a:r>
-              <a:t>(5000 exemples, verdict saine)</a:t>
+              <a:t>(beta=0,3, 5000 exemples, verdict saine)</a:t>
             </a:r>
           </a:p>
         </p:txBody>
@@ -7485,7 +7544,7 @@
               </a:defRPr>
             </a:pPr>
             <a:r>
-              <a:t>• Le DPO a ete entraine avec succes a l'echelle reelle, mais a revele un probleme reel a l'evaluation (degenerescence de generation), diagnostique et corrige : le fil conducteur de la section 3.</a:t>
+              <a:t>• Le DPO a d'abord revele un probleme reel a l'evaluation (degenerescence de generation), diagnostique, corrige (beta=0,3) et reconfirme a l'echelle reelle : le fil conducteur de la section 3.</a:t>
             </a:r>
           </a:p>
         </p:txBody>

</xml_diff>